<commit_message>
Brim information guide updated
</commit_message>
<xml_diff>
--- a/Documents/Original/FlexChroam_Brim_Information_Guide-JP.pptx
+++ b/Documents/Original/FlexChroam_Brim_Information_Guide-JP.pptx
@@ -257,7 +257,7 @@
           <a:p>
             <a:fld id="{71132294-360C-4425-B294-91EF6E97A591}" type="datetimeFigureOut">
               <a:rPr kumimoji="1" lang="ja-JP" altLang="en-US" smtClean="0"/>
-              <a:t>2026/7/24</a:t>
+              <a:t>2026/8/17</a:t>
             </a:fld>
             <a:endParaRPr kumimoji="1" lang="ja-JP" altLang="en-US"/>
           </a:p>
@@ -459,7 +459,7 @@
           <a:p>
             <a:fld id="{71132294-360C-4425-B294-91EF6E97A591}" type="datetimeFigureOut">
               <a:rPr kumimoji="1" lang="ja-JP" altLang="en-US" smtClean="0"/>
-              <a:t>2026/7/24</a:t>
+              <a:t>2026/8/17</a:t>
             </a:fld>
             <a:endParaRPr kumimoji="1" lang="ja-JP" altLang="en-US"/>
           </a:p>
@@ -671,7 +671,7 @@
           <a:p>
             <a:fld id="{71132294-360C-4425-B294-91EF6E97A591}" type="datetimeFigureOut">
               <a:rPr kumimoji="1" lang="ja-JP" altLang="en-US" smtClean="0"/>
-              <a:t>2026/7/24</a:t>
+              <a:t>2026/8/17</a:t>
             </a:fld>
             <a:endParaRPr kumimoji="1" lang="ja-JP" altLang="en-US"/>
           </a:p>
@@ -895,7 +895,7 @@
           <a:p>
             <a:fld id="{71132294-360C-4425-B294-91EF6E97A591}" type="datetimeFigureOut">
               <a:rPr kumimoji="1" lang="ja-JP" altLang="en-US" smtClean="0"/>
-              <a:t>2026/7/24</a:t>
+              <a:t>2026/8/17</a:t>
             </a:fld>
             <a:endParaRPr kumimoji="1" lang="ja-JP" altLang="en-US"/>
           </a:p>
@@ -1141,7 +1141,7 @@
           <a:p>
             <a:fld id="{71132294-360C-4425-B294-91EF6E97A591}" type="datetimeFigureOut">
               <a:rPr kumimoji="1" lang="ja-JP" altLang="en-US" smtClean="0"/>
-              <a:t>2026/7/24</a:t>
+              <a:t>2026/8/17</a:t>
             </a:fld>
             <a:endParaRPr kumimoji="1" lang="ja-JP" altLang="en-US"/>
           </a:p>
@@ -1437,7 +1437,7 @@
           <a:p>
             <a:fld id="{71132294-360C-4425-B294-91EF6E97A591}" type="datetimeFigureOut">
               <a:rPr kumimoji="1" lang="ja-JP" altLang="en-US" smtClean="0"/>
-              <a:t>2026/7/24</a:t>
+              <a:t>2026/8/17</a:t>
             </a:fld>
             <a:endParaRPr kumimoji="1" lang="ja-JP" altLang="en-US"/>
           </a:p>
@@ -1868,7 +1868,7 @@
           <a:p>
             <a:fld id="{71132294-360C-4425-B294-91EF6E97A591}" type="datetimeFigureOut">
               <a:rPr kumimoji="1" lang="ja-JP" altLang="en-US" smtClean="0"/>
-              <a:t>2026/7/24</a:t>
+              <a:t>2026/8/17</a:t>
             </a:fld>
             <a:endParaRPr kumimoji="1" lang="ja-JP" altLang="en-US"/>
           </a:p>
@@ -1986,7 +1986,7 @@
           <a:p>
             <a:fld id="{71132294-360C-4425-B294-91EF6E97A591}" type="datetimeFigureOut">
               <a:rPr kumimoji="1" lang="ja-JP" altLang="en-US" smtClean="0"/>
-              <a:t>2026/7/24</a:t>
+              <a:t>2026/8/17</a:t>
             </a:fld>
             <a:endParaRPr kumimoji="1" lang="ja-JP" altLang="en-US"/>
           </a:p>
@@ -2081,7 +2081,7 @@
           <a:p>
             <a:fld id="{71132294-360C-4425-B294-91EF6E97A591}" type="datetimeFigureOut">
               <a:rPr kumimoji="1" lang="ja-JP" altLang="en-US" smtClean="0"/>
-              <a:t>2026/7/24</a:t>
+              <a:t>2026/8/17</a:t>
             </a:fld>
             <a:endParaRPr kumimoji="1" lang="ja-JP" altLang="en-US"/>
           </a:p>
@@ -2390,7 +2390,7 @@
           <a:p>
             <a:fld id="{71132294-360C-4425-B294-91EF6E97A591}" type="datetimeFigureOut">
               <a:rPr kumimoji="1" lang="ja-JP" altLang="en-US" smtClean="0"/>
-              <a:t>2026/7/24</a:t>
+              <a:t>2026/8/17</a:t>
             </a:fld>
             <a:endParaRPr kumimoji="1" lang="ja-JP" altLang="en-US"/>
           </a:p>
@@ -2647,7 +2647,7 @@
           <a:p>
             <a:fld id="{71132294-360C-4425-B294-91EF6E97A591}" type="datetimeFigureOut">
               <a:rPr kumimoji="1" lang="ja-JP" altLang="en-US" smtClean="0"/>
-              <a:t>2026/7/24</a:t>
+              <a:t>2026/8/17</a:t>
             </a:fld>
             <a:endParaRPr kumimoji="1" lang="ja-JP" altLang="en-US"/>
           </a:p>
@@ -2892,7 +2892,7 @@
           <a:p>
             <a:fld id="{71132294-360C-4425-B294-91EF6E97A591}" type="datetimeFigureOut">
               <a:rPr kumimoji="1" lang="ja-JP" altLang="en-US" smtClean="0"/>
-              <a:t>2026/7/24</a:t>
+              <a:t>2026/8/17</a:t>
             </a:fld>
             <a:endParaRPr kumimoji="1" lang="ja-JP" altLang="en-US"/>
           </a:p>
@@ -6106,8 +6106,8 @@
         </p:nvSpPr>
         <p:spPr>
           <a:xfrm>
-            <a:off x="646571" y="840586"/>
-            <a:ext cx="5729069" cy="1077218"/>
+            <a:off x="1121732" y="822505"/>
+            <a:ext cx="5361981" cy="584775"/>
           </a:xfrm>
           <a:prstGeom prst="rect">
             <a:avLst/>
@@ -6126,7 +6126,7 @@
                 <a:ea typeface="IBM Plex Sans JP" panose="020B0503050203000203" pitchFamily="50" charset="-128"/>
                 <a:cs typeface="Segoe UI Semibold" panose="020B0702040204020203" pitchFamily="34" charset="0"/>
               </a:rPr>
-              <a:t>FlexChroma™</a:t>
+              <a:t>FlexChroma</a:t>
             </a:r>
             <a:r>
               <a:rPr lang="en-US" altLang="ja-JP" sz="3200" b="1" dirty="0">
@@ -6136,21 +6136,15 @@
               <a:t> </a:t>
             </a:r>
             <a:r>
-              <a:rPr lang="ja-JP" altLang="en-US" sz="2800" b="1" dirty="0">
+              <a:rPr lang="ja-JP" altLang="en-US" sz="2600" b="1" dirty="0">
                 <a:latin typeface="+mj-ea"/>
                 <a:ea typeface="+mj-ea"/>
               </a:rPr>
               <a:t>ブリム情報ガイド</a:t>
             </a:r>
-            <a:endParaRPr lang="ja-JP" altLang="ja-JP" sz="2900" dirty="0">
+            <a:endParaRPr lang="ja-JP" altLang="ja-JP" sz="2600" dirty="0">
               <a:latin typeface="+mj-ea"/>
               <a:ea typeface="+mj-ea"/>
-            </a:endParaRPr>
-          </a:p>
-          <a:p>
-            <a:endParaRPr kumimoji="1" lang="ja-JP" altLang="en-US" sz="3200" b="1" dirty="0">
-              <a:latin typeface="IBM Plex Sans JP" panose="020B0503050203000203" pitchFamily="50" charset="-128"/>
-              <a:ea typeface="IBM Plex Sans JP" panose="020B0503050203000203" pitchFamily="50" charset="-128"/>
             </a:endParaRPr>
           </a:p>
         </p:txBody>
@@ -6932,6 +6926,42 @@
           </a:p>
         </p:txBody>
       </p:sp>
+      <p:pic>
+        <p:nvPicPr>
+          <p:cNvPr id="25" name="図 24">
+            <a:extLst>
+              <a:ext uri="{FF2B5EF4-FFF2-40B4-BE49-F238E27FC236}">
+                <a16:creationId xmlns:a16="http://schemas.microsoft.com/office/drawing/2014/main" id="{A0E89525-5247-AF3C-5FD8-AA2A2F98961F}"/>
+              </a:ext>
+            </a:extLst>
+          </p:cNvPr>
+          <p:cNvPicPr>
+            <a:picLocks noChangeAspect="1"/>
+          </p:cNvPicPr>
+          <p:nvPr/>
+        </p:nvPicPr>
+        <p:blipFill>
+          <a:blip r:embed="rId3">
+            <a:extLst>
+              <a:ext uri="{28A0092B-C50C-407E-A947-70E740481C1C}">
+                <a14:useLocalDpi xmlns:a14="http://schemas.microsoft.com/office/drawing/2010/main" val="0"/>
+              </a:ext>
+            </a:extLst>
+          </a:blip>
+          <a:stretch>
+            <a:fillRect/>
+          </a:stretch>
+        </p:blipFill>
+        <p:spPr>
+          <a:xfrm>
+            <a:off x="745539" y="866839"/>
+            <a:ext cx="430172" cy="414690"/>
+          </a:xfrm>
+          <a:prstGeom prst="rect">
+            <a:avLst/>
+          </a:prstGeom>
+        </p:spPr>
+      </p:pic>
     </p:spTree>
     <p:extLst>
       <p:ext uri="{BB962C8B-B14F-4D97-AF65-F5344CB8AC3E}">
@@ -12498,69 +12528,6 @@
       </p:sp>
       <p:sp>
         <p:nvSpPr>
-          <p:cNvPr id="2" name="テキスト ボックス 1">
-            <a:extLst>
-              <a:ext uri="{FF2B5EF4-FFF2-40B4-BE49-F238E27FC236}">
-                <a16:creationId xmlns:a16="http://schemas.microsoft.com/office/drawing/2014/main" id="{309D5A08-B487-407E-803B-60D2A557F176}"/>
-              </a:ext>
-            </a:extLst>
-          </p:cNvPr>
-          <p:cNvSpPr txBox="1"/>
-          <p:nvPr/>
-        </p:nvSpPr>
-        <p:spPr>
-          <a:xfrm>
-            <a:off x="646571" y="840586"/>
-            <a:ext cx="5729069" cy="1077218"/>
-          </a:xfrm>
-          <a:prstGeom prst="rect">
-            <a:avLst/>
-          </a:prstGeom>
-          <a:noFill/>
-        </p:spPr>
-        <p:txBody>
-          <a:bodyPr wrap="none" rtlCol="0">
-            <a:spAutoFit/>
-          </a:bodyPr>
-          <a:lstStyle/>
-          <a:p>
-            <a:r>
-              <a:rPr lang="en-US" altLang="ja-JP" sz="3200" b="1" dirty="0">
-                <a:latin typeface="Segoe UI Semibold" panose="020B0702040204020203" pitchFamily="34" charset="0"/>
-                <a:ea typeface="IBM Plex Sans JP" panose="020B0503050203000203" pitchFamily="50" charset="-128"/>
-                <a:cs typeface="Segoe UI Semibold" panose="020B0702040204020203" pitchFamily="34" charset="0"/>
-              </a:rPr>
-              <a:t>FlexChroma™</a:t>
-            </a:r>
-            <a:r>
-              <a:rPr lang="en-US" altLang="ja-JP" sz="3200" b="1" dirty="0">
-                <a:latin typeface="IBM Plex Sans JP" panose="020B0503050203000203" pitchFamily="50" charset="-128"/>
-                <a:ea typeface="IBM Plex Sans JP" panose="020B0503050203000203" pitchFamily="50" charset="-128"/>
-              </a:rPr>
-              <a:t> </a:t>
-            </a:r>
-            <a:r>
-              <a:rPr lang="ja-JP" altLang="en-US" sz="2800" b="1" dirty="0">
-                <a:latin typeface="+mj-ea"/>
-                <a:ea typeface="+mj-ea"/>
-              </a:rPr>
-              <a:t>ブリム情報ガイド</a:t>
-            </a:r>
-            <a:endParaRPr lang="ja-JP" altLang="ja-JP" sz="2900" dirty="0">
-              <a:latin typeface="+mj-ea"/>
-              <a:ea typeface="+mj-ea"/>
-            </a:endParaRPr>
-          </a:p>
-          <a:p>
-            <a:endParaRPr kumimoji="1" lang="ja-JP" altLang="en-US" sz="3200" b="1" dirty="0">
-              <a:latin typeface="IBM Plex Sans JP" panose="020B0503050203000203" pitchFamily="50" charset="-128"/>
-              <a:ea typeface="IBM Plex Sans JP" panose="020B0503050203000203" pitchFamily="50" charset="-128"/>
-            </a:endParaRPr>
-          </a:p>
-        </p:txBody>
-      </p:sp>
-      <p:sp>
-        <p:nvSpPr>
           <p:cNvPr id="18" name="テキスト ボックス 17">
             <a:extLst>
               <a:ext uri="{FF2B5EF4-FFF2-40B4-BE49-F238E27FC236}">
@@ -12960,6 +12927,99 @@
           </a:p>
         </p:txBody>
       </p:sp>
+      <p:sp>
+        <p:nvSpPr>
+          <p:cNvPr id="4" name="テキスト ボックス 3">
+            <a:extLst>
+              <a:ext uri="{FF2B5EF4-FFF2-40B4-BE49-F238E27FC236}">
+                <a16:creationId xmlns:a16="http://schemas.microsoft.com/office/drawing/2014/main" id="{24E0F7C8-B1B4-ADD0-E90E-98F3988208DD}"/>
+              </a:ext>
+            </a:extLst>
+          </p:cNvPr>
+          <p:cNvSpPr txBox="1"/>
+          <p:nvPr/>
+        </p:nvSpPr>
+        <p:spPr>
+          <a:xfrm>
+            <a:off x="1121732" y="822505"/>
+            <a:ext cx="5361981" cy="584775"/>
+          </a:xfrm>
+          <a:prstGeom prst="rect">
+            <a:avLst/>
+          </a:prstGeom>
+          <a:noFill/>
+        </p:spPr>
+        <p:txBody>
+          <a:bodyPr wrap="none" rtlCol="0">
+            <a:spAutoFit/>
+          </a:bodyPr>
+          <a:lstStyle/>
+          <a:p>
+            <a:r>
+              <a:rPr lang="en-US" altLang="ja-JP" sz="3200" b="1" dirty="0">
+                <a:latin typeface="Segoe UI Semibold" panose="020B0702040204020203" pitchFamily="34" charset="0"/>
+                <a:ea typeface="IBM Plex Sans JP" panose="020B0503050203000203" pitchFamily="50" charset="-128"/>
+                <a:cs typeface="Segoe UI Semibold" panose="020B0702040204020203" pitchFamily="34" charset="0"/>
+              </a:rPr>
+              <a:t>FlexChroma</a:t>
+            </a:r>
+            <a:r>
+              <a:rPr lang="en-US" altLang="ja-JP" sz="3200" b="1" dirty="0">
+                <a:latin typeface="IBM Plex Sans JP" panose="020B0503050203000203" pitchFamily="50" charset="-128"/>
+                <a:ea typeface="IBM Plex Sans JP" panose="020B0503050203000203" pitchFamily="50" charset="-128"/>
+              </a:rPr>
+              <a:t> </a:t>
+            </a:r>
+            <a:r>
+              <a:rPr lang="ja-JP" altLang="en-US" sz="2600" b="1" dirty="0">
+                <a:latin typeface="+mj-ea"/>
+                <a:ea typeface="+mj-ea"/>
+              </a:rPr>
+              <a:t>ブリム情報ガイド</a:t>
+            </a:r>
+            <a:endParaRPr lang="ja-JP" altLang="ja-JP" sz="2600" dirty="0">
+              <a:latin typeface="+mj-ea"/>
+              <a:ea typeface="+mj-ea"/>
+            </a:endParaRPr>
+          </a:p>
+        </p:txBody>
+      </p:sp>
+      <p:pic>
+        <p:nvPicPr>
+          <p:cNvPr id="6" name="図 5">
+            <a:extLst>
+              <a:ext uri="{FF2B5EF4-FFF2-40B4-BE49-F238E27FC236}">
+                <a16:creationId xmlns:a16="http://schemas.microsoft.com/office/drawing/2014/main" id="{DDB22BB7-E5C9-C378-D9AD-F27E2CCF0125}"/>
+              </a:ext>
+            </a:extLst>
+          </p:cNvPr>
+          <p:cNvPicPr>
+            <a:picLocks noChangeAspect="1"/>
+          </p:cNvPicPr>
+          <p:nvPr/>
+        </p:nvPicPr>
+        <p:blipFill>
+          <a:blip r:embed="rId3">
+            <a:extLst>
+              <a:ext uri="{28A0092B-C50C-407E-A947-70E740481C1C}">
+                <a14:useLocalDpi xmlns:a14="http://schemas.microsoft.com/office/drawing/2010/main" val="0"/>
+              </a:ext>
+            </a:extLst>
+          </a:blip>
+          <a:stretch>
+            <a:fillRect/>
+          </a:stretch>
+        </p:blipFill>
+        <p:spPr>
+          <a:xfrm>
+            <a:off x="745539" y="866839"/>
+            <a:ext cx="430172" cy="414690"/>
+          </a:xfrm>
+          <a:prstGeom prst="rect">
+            <a:avLst/>
+          </a:prstGeom>
+        </p:spPr>
+      </p:pic>
     </p:spTree>
     <p:extLst>
       <p:ext uri="{BB962C8B-B14F-4D97-AF65-F5344CB8AC3E}">

</xml_diff>